<commit_message>
Remove owner name from slides; use branded URLs and email
</commit_message>
<xml_diff>
--- a/Little-Blossoms-Website-Presentation.pptx
+++ b/Little-Blossoms-Website-Presentation.pptx
@@ -2219,7 +2219,7 @@
                 <a:ea typeface="Calibri" pitchFamily="34" charset="-122"/>
                 <a:cs typeface="Calibri" pitchFamily="34" charset="-120"/>
               </a:rPr>
-              <a:t>WhatsApp +91 90000 00000  |  kapilanjavascript.github.io/little-blossoms-site</a:t>
+              <a:t>WhatsApp +91 90000 00000  |  hello@littleblossoms.in</a:t>
             </a:r>
             <a:endParaRPr lang="en-US" sz="1400" dirty="0"/>
           </a:p>
@@ -7603,7 +7603,7 @@
                 <a:ea typeface="Calibri" pitchFamily="34" charset="-122"/>
                 <a:cs typeface="Calibri" pitchFamily="34" charset="-120"/>
               </a:rPr>
-              <a:t>github.com/KapilanJavaScript/little-blossoms-website (dedicated, fresh)</a:t>
+              <a:t>little-blossoms.higgsfield.app — the main site</a:t>
             </a:r>
             <a:endParaRPr lang="en-US" sz="1400" dirty="0"/>
           </a:p>
@@ -7703,7 +7703,7 @@
                 <a:ea typeface="Calibri" pitchFamily="34" charset="-122"/>
                 <a:cs typeface="Calibri" pitchFamily="34" charset="-120"/>
               </a:rPr>
-              <a:t>GitHub Pages: kapilanjavascript.github.io/little-blossoms-site</a:t>
+              <a:t>Website repository — deployed and version-controlled</a:t>
             </a:r>
             <a:endParaRPr lang="en-US" sz="1400" dirty="0"/>
           </a:p>

</xml_diff>